<commit_message>
Add business case slide anchored to Chief Peterson's cost model
New Slide 5b "Same Spend, Dramatically Better Care" between the
care-quality bottom-line slide and the thank-you slide. Three
scenario cards (A=$1.00M, B=$851K, C=$902K recommended) built from
Peterson's 24/7 ALS projection ($250K net per station) scaled to
K=4 and compared against the $2.36M current distributed overhead.
Speaker notes updated with 25-second business-case script, new
Q&A entry for "walk me through the cost math", and rehearsal
checklist items for the Peterson numbers.

Co-Authored-By: Claude Opus 4.7 (1M context) <noreply@anthropic.com>
</commit_message>
<xml_diff>
--- a/pitch_deck_jefferson_ems.pptx
+++ b/pitch_deck_jefferson_ems.pptx
@@ -11,6 +11,7 @@
     <p:sldId id="259" r:id="rId10"/>
     <p:sldId id="260" r:id="rId11"/>
     <p:sldId id="261" r:id="rId12"/>
+    <p:sldId id="262" r:id="rId13"/>
   </p:sldIdLst>
   <p:sldSz cx="12191695" cy="6858000" type="screen4x3"/>
   <p:notesSz cx="6858000" cy="9144000"/>
@@ -8039,6 +8040,1631 @@
 </file>
 
 <file path=ppt/slides/slide6.xml><?xml version="1.0" encoding="utf-8"?>
+<p:sld xmlns:a="http://schemas.openxmlformats.org/drawingml/2006/main" xmlns:p="http://schemas.openxmlformats.org/presentationml/2006/main" xmlns:r="http://schemas.openxmlformats.org/officeDocument/2006/relationships">
+  <p:cSld>
+    <p:spTree>
+      <p:nvGrpSpPr>
+        <p:cNvPr id="1" name=""/>
+        <p:cNvGrpSpPr/>
+        <p:nvPr/>
+      </p:nvGrpSpPr>
+      <p:grpSpPr/>
+      <p:sp>
+        <p:nvSpPr>
+          <p:cNvPr id="2" name="TextBox 1"/>
+          <p:cNvSpPr txBox="1"/>
+          <p:nvPr/>
+        </p:nvSpPr>
+        <p:spPr>
+          <a:xfrm>
+            <a:off x="457200" y="274320"/>
+            <a:ext cx="11247120" cy="731520"/>
+          </a:xfrm>
+          <a:prstGeom prst="rect">
+            <a:avLst/>
+          </a:prstGeom>
+          <a:noFill/>
+        </p:spPr>
+        <p:txBody>
+          <a:bodyPr wrap="square" anchor="t" lIns="73152" rIns="73152">
+            <a:spAutoFit/>
+          </a:bodyPr>
+          <a:lstStyle/>
+          <a:p>
+            <a:pPr algn="ctr">
+              <a:lnSpc>
+                <a:spcPct val="115000"/>
+              </a:lnSpc>
+            </a:pPr>
+            <a:r>
+              <a:rPr sz="3000" b="1" i="0">
+                <a:solidFill>
+                  <a:srgbClr val="111111"/>
+                </a:solidFill>
+                <a:latin typeface="Calibri"/>
+              </a:rPr>
+              <a:t>The Business Case: Same Spend, Dramatically Better Care</a:t>
+            </a:r>
+          </a:p>
+        </p:txBody>
+      </p:sp>
+      <p:sp>
+        <p:nvSpPr>
+          <p:cNvPr id="3" name="TextBox 2"/>
+          <p:cNvSpPr txBox="1"/>
+          <p:nvPr/>
+        </p:nvSpPr>
+        <p:spPr>
+          <a:xfrm>
+            <a:off x="457200" y="1005840"/>
+            <a:ext cx="11247120" cy="457200"/>
+          </a:xfrm>
+          <a:prstGeom prst="rect">
+            <a:avLst/>
+          </a:prstGeom>
+          <a:noFill/>
+        </p:spPr>
+        <p:txBody>
+          <a:bodyPr wrap="square" anchor="t" lIns="73152" rIns="73152">
+            <a:spAutoFit/>
+          </a:bodyPr>
+          <a:lstStyle/>
+          <a:p>
+            <a:pPr algn="ctr">
+              <a:lnSpc>
+                <a:spcPct val="115000"/>
+              </a:lnSpc>
+            </a:pPr>
+            <a:r>
+              <a:rPr sz="1300" b="0" i="1">
+                <a:solidFill>
+                  <a:srgbClr val="555555"/>
+                </a:solidFill>
+                <a:latin typeface="Calibri"/>
+              </a:rPr>
+              <a:t>Built on Chief Peterson's 24/7 ALS single-unit cost model (6 FTEs, 24/48 schedule, 700 calls/yr)</a:t>
+            </a:r>
+          </a:p>
+        </p:txBody>
+      </p:sp>
+      <p:sp>
+        <p:nvSpPr>
+          <p:cNvPr id="4" name="Rounded Rectangle 3"/>
+          <p:cNvSpPr/>
+          <p:nvPr/>
+        </p:nvSpPr>
+        <p:spPr>
+          <a:xfrm>
+            <a:off x="457200" y="1737360"/>
+            <a:ext cx="3657600" cy="4114800"/>
+          </a:xfrm>
+          <a:prstGeom prst="roundRect">
+            <a:avLst/>
+          </a:prstGeom>
+          <a:solidFill>
+            <a:srgbClr val="FFF5F5"/>
+          </a:solidFill>
+          <a:ln w="25400">
+            <a:solidFill>
+              <a:srgbClr val="B22222"/>
+            </a:solidFill>
+          </a:ln>
+        </p:spPr>
+        <p:style>
+          <a:lnRef idx="1">
+            <a:schemeClr val="accent1"/>
+          </a:lnRef>
+          <a:fillRef idx="3">
+            <a:schemeClr val="accent1"/>
+          </a:fillRef>
+          <a:effectRef idx="2">
+            <a:schemeClr val="accent1"/>
+          </a:effectRef>
+          <a:fontRef idx="minor">
+            <a:schemeClr val="lt1"/>
+          </a:fontRef>
+        </p:style>
+        <p:txBody>
+          <a:bodyPr rtlCol="0" anchor="ctr"/>
+          <a:lstStyle/>
+          <a:p/>
+        </p:txBody>
+      </p:sp>
+      <p:sp>
+        <p:nvSpPr>
+          <p:cNvPr id="5" name="TextBox 4"/>
+          <p:cNvSpPr txBox="1"/>
+          <p:nvPr/>
+        </p:nvSpPr>
+        <p:spPr>
+          <a:xfrm>
+            <a:off x="457200" y="1874519"/>
+            <a:ext cx="3657600" cy="457200"/>
+          </a:xfrm>
+          <a:prstGeom prst="rect">
+            <a:avLst/>
+          </a:prstGeom>
+          <a:noFill/>
+        </p:spPr>
+        <p:txBody>
+          <a:bodyPr wrap="square" anchor="t" lIns="73152" rIns="73152">
+            <a:spAutoFit/>
+          </a:bodyPr>
+          <a:lstStyle/>
+          <a:p>
+            <a:pPr algn="ctr">
+              <a:lnSpc>
+                <a:spcPct val="115000"/>
+              </a:lnSpc>
+            </a:pPr>
+            <a:r>
+              <a:rPr sz="1800" b="1" i="0">
+                <a:solidFill>
+                  <a:srgbClr val="B22222"/>
+                </a:solidFill>
+                <a:latin typeface="Calibri"/>
+              </a:rPr>
+              <a:t>TODAY — Fragmented</a:t>
+            </a:r>
+          </a:p>
+        </p:txBody>
+      </p:sp>
+      <p:sp>
+        <p:nvSpPr>
+          <p:cNvPr id="6" name="TextBox 5"/>
+          <p:cNvSpPr txBox="1"/>
+          <p:nvPr/>
+        </p:nvSpPr>
+        <p:spPr>
+          <a:xfrm>
+            <a:off x="594360" y="2377440"/>
+            <a:ext cx="3383280" cy="365760"/>
+          </a:xfrm>
+          <a:prstGeom prst="rect">
+            <a:avLst/>
+          </a:prstGeom>
+          <a:noFill/>
+        </p:spPr>
+        <p:txBody>
+          <a:bodyPr wrap="square" anchor="t" lIns="73152" rIns="73152">
+            <a:spAutoFit/>
+          </a:bodyPr>
+          <a:lstStyle/>
+          <a:p>
+            <a:pPr algn="l">
+              <a:lnSpc>
+                <a:spcPct val="115000"/>
+              </a:lnSpc>
+            </a:pPr>
+            <a:r>
+              <a:rPr sz="1200" b="0" i="0">
+                <a:solidFill>
+                  <a:srgbClr val="555555"/>
+                </a:solidFill>
+                <a:latin typeface="Calibri"/>
+              </a:rPr>
+              <a:t>Current distributed overhead</a:t>
+            </a:r>
+          </a:p>
+        </p:txBody>
+      </p:sp>
+      <p:sp>
+        <p:nvSpPr>
+          <p:cNvPr id="7" name="TextBox 6"/>
+          <p:cNvSpPr txBox="1"/>
+          <p:nvPr/>
+        </p:nvSpPr>
+        <p:spPr>
+          <a:xfrm>
+            <a:off x="594360" y="2697480"/>
+            <a:ext cx="3383280" cy="822960"/>
+          </a:xfrm>
+          <a:prstGeom prst="rect">
+            <a:avLst/>
+          </a:prstGeom>
+          <a:noFill/>
+        </p:spPr>
+        <p:txBody>
+          <a:bodyPr wrap="square" anchor="t" lIns="73152" rIns="73152">
+            <a:spAutoFit/>
+          </a:bodyPr>
+          <a:lstStyle/>
+          <a:p>
+            <a:pPr algn="l">
+              <a:lnSpc>
+                <a:spcPct val="115000"/>
+              </a:lnSpc>
+            </a:pPr>
+            <a:r>
+              <a:rPr sz="4800" b="1" i="0">
+                <a:solidFill>
+                  <a:srgbClr val="B22222"/>
+                </a:solidFill>
+                <a:latin typeface="Calibri"/>
+              </a:rPr>
+              <a:t>$2.36M</a:t>
+            </a:r>
+          </a:p>
+        </p:txBody>
+      </p:sp>
+      <p:sp>
+        <p:nvSpPr>
+          <p:cNvPr id="8" name="TextBox 7"/>
+          <p:cNvSpPr txBox="1"/>
+          <p:nvPr/>
+        </p:nvSpPr>
+        <p:spPr>
+          <a:xfrm>
+            <a:off x="594360" y="3520440"/>
+            <a:ext cx="3383280" cy="365760"/>
+          </a:xfrm>
+          <a:prstGeom prst="rect">
+            <a:avLst/>
+          </a:prstGeom>
+          <a:noFill/>
+        </p:spPr>
+        <p:txBody>
+          <a:bodyPr wrap="square" anchor="t" lIns="73152" rIns="73152">
+            <a:spAutoFit/>
+          </a:bodyPr>
+          <a:lstStyle/>
+          <a:p>
+            <a:pPr algn="l">
+              <a:lnSpc>
+                <a:spcPct val="115000"/>
+              </a:lnSpc>
+            </a:pPr>
+            <a:r>
+              <a:rPr sz="1200" b="0" i="1">
+                <a:solidFill>
+                  <a:srgbClr val="555555"/>
+                </a:solidFill>
+                <a:latin typeface="Calibri"/>
+              </a:rPr>
+              <a:t>per year, across 7 departments</a:t>
+            </a:r>
+          </a:p>
+        </p:txBody>
+      </p:sp>
+      <p:cxnSp>
+        <p:nvCxnSpPr>
+          <p:cNvPr id="9" name="Connector 8"/>
+          <p:cNvCxnSpPr/>
+          <p:nvPr/>
+        </p:nvCxnSpPr>
+        <p:spPr>
+          <a:xfrm>
+            <a:off x="640080" y="3977639"/>
+            <a:ext cx="3291840" cy="0"/>
+          </a:xfrm>
+          <a:prstGeom prst="bentConnector3">
+            <a:avLst/>
+          </a:prstGeom>
+          <a:ln w="12700">
+            <a:solidFill>
+              <a:srgbClr val="CCCCCC"/>
+            </a:solidFill>
+          </a:ln>
+        </p:spPr>
+        <p:style>
+          <a:lnRef idx="2">
+            <a:schemeClr val="accent1"/>
+          </a:lnRef>
+          <a:fillRef idx="0">
+            <a:schemeClr val="accent1"/>
+          </a:fillRef>
+          <a:effectRef idx="1">
+            <a:schemeClr val="accent1"/>
+          </a:effectRef>
+          <a:fontRef idx="minor">
+            <a:schemeClr val="tx1"/>
+          </a:fontRef>
+        </p:style>
+      </p:cxnSp>
+      <p:sp>
+        <p:nvSpPr>
+          <p:cNvPr id="10" name="TextBox 9"/>
+          <p:cNvSpPr txBox="1"/>
+          <p:nvPr/>
+        </p:nvSpPr>
+        <p:spPr>
+          <a:xfrm>
+            <a:off x="640080" y="4114800"/>
+            <a:ext cx="3291840" cy="1645920"/>
+          </a:xfrm>
+          <a:prstGeom prst="rect">
+            <a:avLst/>
+          </a:prstGeom>
+          <a:noFill/>
+        </p:spPr>
+        <p:txBody>
+          <a:bodyPr wrap="square" anchor="t" lIns="73152" rIns="73152">
+            <a:spAutoFit/>
+          </a:bodyPr>
+          <a:lstStyle/>
+          <a:p>
+            <a:pPr algn="l">
+              <a:spcAft>
+                <a:spcPts val="600"/>
+              </a:spcAft>
+            </a:pPr>
+            <a:r>
+              <a:rPr sz="1100" b="1" i="0">
+                <a:solidFill>
+                  <a:srgbClr val="555555"/>
+                </a:solidFill>
+                <a:latin typeface="Calibri"/>
+              </a:rPr>
+              <a:t>What that buys today:</a:t>
+            </a:r>
+          </a:p>
+          <a:p>
+            <a:pPr algn="l">
+              <a:spcAft>
+                <a:spcPts val="300"/>
+              </a:spcAft>
+            </a:pPr>
+            <a:r>
+              <a:rPr sz="1100" b="0" i="0">
+                <a:solidFill>
+                  <a:srgbClr val="111111"/>
+                </a:solidFill>
+                <a:latin typeface="Calibri"/>
+              </a:rPr>
+              <a:t>• 12 independent backup ambulances</a:t>
+            </a:r>
+          </a:p>
+          <a:p>
+            <a:pPr algn="l">
+              <a:spcAft>
+                <a:spcPts val="300"/>
+              </a:spcAft>
+            </a:pPr>
+            <a:r>
+              <a:rPr sz="1100" b="0" i="0">
+                <a:solidFill>
+                  <a:srgbClr val="111111"/>
+                </a:solidFill>
+                <a:latin typeface="Calibri"/>
+              </a:rPr>
+              <a:t>• 10–15% utilization per unit</a:t>
+            </a:r>
+          </a:p>
+          <a:p>
+            <a:pPr algn="l">
+              <a:spcAft>
+                <a:spcPts val="300"/>
+              </a:spcAft>
+            </a:pPr>
+            <a:r>
+              <a:rPr sz="1100" b="1" i="0">
+                <a:solidFill>
+                  <a:srgbClr val="B22222"/>
+                </a:solidFill>
+                <a:latin typeface="Calibri"/>
+              </a:rPr>
+              <a:t>• 41 all-busy gaps per year</a:t>
+            </a:r>
+          </a:p>
+          <a:p>
+            <a:pPr algn="l"/>
+            <a:r>
+              <a:rPr sz="1100" b="0" i="0">
+                <a:solidFill>
+                  <a:srgbClr val="111111"/>
+                </a:solidFill>
+                <a:latin typeface="Calibri"/>
+              </a:rPr>
+              <a:t>• Only 32% of concurrent demand covered ≤14 min</a:t>
+            </a:r>
+          </a:p>
+        </p:txBody>
+      </p:sp>
+      <p:cxnSp>
+        <p:nvCxnSpPr>
+          <p:cNvPr id="11" name="Connector 10"/>
+          <p:cNvCxnSpPr/>
+          <p:nvPr/>
+        </p:nvCxnSpPr>
+        <p:spPr>
+          <a:xfrm>
+            <a:off x="4297680" y="3657600"/>
+            <a:ext cx="365760" cy="0"/>
+          </a:xfrm>
+          <a:prstGeom prst="line">
+            <a:avLst/>
+          </a:prstGeom>
+          <a:ln w="50800">
+            <a:solidFill>
+              <a:srgbClr val="111111"/>
+            </a:solidFill>
+            <a:tailEnd type="triangle" w="med" h="med"/>
+          </a:ln>
+        </p:spPr>
+        <p:style>
+          <a:lnRef idx="2">
+            <a:schemeClr val="accent1"/>
+          </a:lnRef>
+          <a:fillRef idx="0">
+            <a:schemeClr val="accent1"/>
+          </a:fillRef>
+          <a:effectRef idx="1">
+            <a:schemeClr val="accent1"/>
+          </a:effectRef>
+          <a:fontRef idx="minor">
+            <a:schemeClr val="tx1"/>
+          </a:fontRef>
+        </p:style>
+      </p:cxnSp>
+      <p:sp>
+        <p:nvSpPr>
+          <p:cNvPr id="12" name="TextBox 11"/>
+          <p:cNvSpPr txBox="1"/>
+          <p:nvPr/>
+        </p:nvSpPr>
+        <p:spPr>
+          <a:xfrm>
+            <a:off x="4023360" y="3200400"/>
+            <a:ext cx="822960" cy="365760"/>
+          </a:xfrm>
+          <a:prstGeom prst="rect">
+            <a:avLst/>
+          </a:prstGeom>
+          <a:noFill/>
+        </p:spPr>
+        <p:txBody>
+          <a:bodyPr wrap="square" anchor="t" lIns="73152" rIns="73152">
+            <a:spAutoFit/>
+          </a:bodyPr>
+          <a:lstStyle/>
+          <a:p>
+            <a:pPr algn="ctr">
+              <a:lnSpc>
+                <a:spcPct val="110000"/>
+              </a:lnSpc>
+            </a:pPr>
+            <a:r>
+              <a:rPr sz="1100" b="1" i="1">
+                <a:solidFill>
+                  <a:srgbClr val="111111"/>
+                </a:solidFill>
+                <a:latin typeface="Calibri"/>
+              </a:rPr>
+              <a:t>Same
+budget</a:t>
+            </a:r>
+          </a:p>
+        </p:txBody>
+      </p:sp>
+      <p:sp>
+        <p:nvSpPr>
+          <p:cNvPr id="13" name="Rounded Rectangle 12"/>
+          <p:cNvSpPr/>
+          <p:nvPr/>
+        </p:nvSpPr>
+        <p:spPr>
+          <a:xfrm>
+            <a:off x="4846320" y="1737360"/>
+            <a:ext cx="6903720" cy="4114800"/>
+          </a:xfrm>
+          <a:prstGeom prst="roundRect">
+            <a:avLst/>
+          </a:prstGeom>
+          <a:solidFill>
+            <a:srgbClr val="F0F8FF"/>
+          </a:solidFill>
+          <a:ln w="25400">
+            <a:solidFill>
+              <a:srgbClr val="2C7FB8"/>
+            </a:solidFill>
+          </a:ln>
+        </p:spPr>
+        <p:style>
+          <a:lnRef idx="1">
+            <a:schemeClr val="accent1"/>
+          </a:lnRef>
+          <a:fillRef idx="3">
+            <a:schemeClr val="accent1"/>
+          </a:fillRef>
+          <a:effectRef idx="2">
+            <a:schemeClr val="accent1"/>
+          </a:effectRef>
+          <a:fontRef idx="minor">
+            <a:schemeClr val="lt1"/>
+          </a:fontRef>
+        </p:style>
+        <p:txBody>
+          <a:bodyPr rtlCol="0" anchor="ctr"/>
+          <a:lstStyle/>
+          <a:p/>
+        </p:txBody>
+      </p:sp>
+      <p:sp>
+        <p:nvSpPr>
+          <p:cNvPr id="14" name="TextBox 13"/>
+          <p:cNvSpPr txBox="1"/>
+          <p:nvPr/>
+        </p:nvSpPr>
+        <p:spPr>
+          <a:xfrm>
+            <a:off x="4846320" y="1874519"/>
+            <a:ext cx="6903720" cy="457200"/>
+          </a:xfrm>
+          <a:prstGeom prst="rect">
+            <a:avLst/>
+          </a:prstGeom>
+          <a:noFill/>
+        </p:spPr>
+        <p:txBody>
+          <a:bodyPr wrap="square" anchor="t" lIns="73152" rIns="73152">
+            <a:spAutoFit/>
+          </a:bodyPr>
+          <a:lstStyle/>
+          <a:p>
+            <a:pPr algn="ctr">
+              <a:lnSpc>
+                <a:spcPct val="115000"/>
+              </a:lnSpc>
+            </a:pPr>
+            <a:r>
+              <a:rPr sz="1800" b="1" i="0">
+                <a:solidFill>
+                  <a:srgbClr val="2C7FB8"/>
+                </a:solidFill>
+                <a:latin typeface="Calibri"/>
+              </a:rPr>
+              <a:t>TOMORROW — Regional (K=4)</a:t>
+            </a:r>
+          </a:p>
+        </p:txBody>
+      </p:sp>
+      <p:sp>
+        <p:nvSpPr>
+          <p:cNvPr id="15" name="Rounded Rectangle 14"/>
+          <p:cNvSpPr/>
+          <p:nvPr/>
+        </p:nvSpPr>
+        <p:spPr>
+          <a:xfrm>
+            <a:off x="4956048" y="2423160"/>
+            <a:ext cx="2148840" cy="3246120"/>
+          </a:xfrm>
+          <a:prstGeom prst="roundRect">
+            <a:avLst/>
+          </a:prstGeom>
+          <a:solidFill>
+            <a:srgbClr val="FFFFFF"/>
+          </a:solidFill>
+          <a:ln w="15240">
+            <a:solidFill>
+              <a:srgbClr val="2C7FB8"/>
+            </a:solidFill>
+          </a:ln>
+        </p:spPr>
+        <p:style>
+          <a:lnRef idx="1">
+            <a:schemeClr val="accent1"/>
+          </a:lnRef>
+          <a:fillRef idx="3">
+            <a:schemeClr val="accent1"/>
+          </a:fillRef>
+          <a:effectRef idx="2">
+            <a:schemeClr val="accent1"/>
+          </a:effectRef>
+          <a:fontRef idx="minor">
+            <a:schemeClr val="lt1"/>
+          </a:fontRef>
+        </p:style>
+        <p:txBody>
+          <a:bodyPr rtlCol="0" anchor="ctr"/>
+          <a:lstStyle/>
+          <a:p/>
+        </p:txBody>
+      </p:sp>
+      <p:sp>
+        <p:nvSpPr>
+          <p:cNvPr id="16" name="TextBox 15"/>
+          <p:cNvSpPr txBox="1"/>
+          <p:nvPr/>
+        </p:nvSpPr>
+        <p:spPr>
+          <a:xfrm>
+            <a:off x="4956048" y="2514600"/>
+            <a:ext cx="2148840" cy="320040"/>
+          </a:xfrm>
+          <a:prstGeom prst="rect">
+            <a:avLst/>
+          </a:prstGeom>
+          <a:noFill/>
+        </p:spPr>
+        <p:txBody>
+          <a:bodyPr wrap="square" anchor="t" lIns="73152" rIns="73152">
+            <a:spAutoFit/>
+          </a:bodyPr>
+          <a:lstStyle/>
+          <a:p>
+            <a:pPr algn="ctr">
+              <a:lnSpc>
+                <a:spcPct val="115000"/>
+              </a:lnSpc>
+            </a:pPr>
+            <a:r>
+              <a:rPr sz="1300" b="1" i="0">
+                <a:solidFill>
+                  <a:srgbClr val="2C7FB8"/>
+                </a:solidFill>
+                <a:latin typeface="Calibri"/>
+              </a:rPr>
+              <a:t>Scenario A</a:t>
+            </a:r>
+          </a:p>
+        </p:txBody>
+      </p:sp>
+      <p:sp>
+        <p:nvSpPr>
+          <p:cNvPr id="17" name="TextBox 16"/>
+          <p:cNvSpPr txBox="1"/>
+          <p:nvPr/>
+        </p:nvSpPr>
+        <p:spPr>
+          <a:xfrm>
+            <a:off x="4956048" y="2834640"/>
+            <a:ext cx="2148840" cy="457200"/>
+          </a:xfrm>
+          <a:prstGeom prst="rect">
+            <a:avLst/>
+          </a:prstGeom>
+          <a:noFill/>
+        </p:spPr>
+        <p:txBody>
+          <a:bodyPr wrap="square" anchor="t" lIns="73152" rIns="73152">
+            <a:spAutoFit/>
+          </a:bodyPr>
+          <a:lstStyle/>
+          <a:p>
+            <a:pPr algn="ctr">
+              <a:lnSpc>
+                <a:spcPct val="115000"/>
+              </a:lnSpc>
+            </a:pPr>
+            <a:r>
+              <a:rPr sz="1000" b="0" i="1">
+                <a:solidFill>
+                  <a:srgbClr val="555555"/>
+                </a:solidFill>
+                <a:latin typeface="Calibri"/>
+              </a:rPr>
+              <a:t>All 4 stations 24/7 ALS</a:t>
+            </a:r>
+          </a:p>
+        </p:txBody>
+      </p:sp>
+      <p:sp>
+        <p:nvSpPr>
+          <p:cNvPr id="18" name="TextBox 17"/>
+          <p:cNvSpPr txBox="1"/>
+          <p:nvPr/>
+        </p:nvSpPr>
+        <p:spPr>
+          <a:xfrm>
+            <a:off x="4956048" y="3383280"/>
+            <a:ext cx="2148840" cy="502920"/>
+          </a:xfrm>
+          <a:prstGeom prst="rect">
+            <a:avLst/>
+          </a:prstGeom>
+          <a:noFill/>
+        </p:spPr>
+        <p:txBody>
+          <a:bodyPr wrap="square" anchor="t" lIns="73152" rIns="73152">
+            <a:spAutoFit/>
+          </a:bodyPr>
+          <a:lstStyle/>
+          <a:p>
+            <a:pPr algn="ctr">
+              <a:lnSpc>
+                <a:spcPct val="115000"/>
+              </a:lnSpc>
+            </a:pPr>
+            <a:r>
+              <a:rPr sz="2600" b="1" i="0">
+                <a:solidFill>
+                  <a:srgbClr val="2C7FB8"/>
+                </a:solidFill>
+                <a:latin typeface="Calibri"/>
+              </a:rPr>
+              <a:t>$1.00M</a:t>
+            </a:r>
+          </a:p>
+        </p:txBody>
+      </p:sp>
+      <p:sp>
+        <p:nvSpPr>
+          <p:cNvPr id="19" name="TextBox 18"/>
+          <p:cNvSpPr txBox="1"/>
+          <p:nvPr/>
+        </p:nvSpPr>
+        <p:spPr>
+          <a:xfrm>
+            <a:off x="4956048" y="3886200"/>
+            <a:ext cx="2148840" cy="274320"/>
+          </a:xfrm>
+          <a:prstGeom prst="rect">
+            <a:avLst/>
+          </a:prstGeom>
+          <a:noFill/>
+        </p:spPr>
+        <p:txBody>
+          <a:bodyPr wrap="square" anchor="t" lIns="73152" rIns="73152">
+            <a:spAutoFit/>
+          </a:bodyPr>
+          <a:lstStyle/>
+          <a:p>
+            <a:pPr algn="ctr">
+              <a:lnSpc>
+                <a:spcPct val="115000"/>
+              </a:lnSpc>
+            </a:pPr>
+            <a:r>
+              <a:rPr sz="1000" b="0" i="1">
+                <a:solidFill>
+                  <a:srgbClr val="555555"/>
+                </a:solidFill>
+                <a:latin typeface="Calibri"/>
+              </a:rPr>
+              <a:t>net / year</a:t>
+            </a:r>
+          </a:p>
+        </p:txBody>
+      </p:sp>
+      <p:sp>
+        <p:nvSpPr>
+          <p:cNvPr id="20" name="TextBox 19"/>
+          <p:cNvSpPr txBox="1"/>
+          <p:nvPr/>
+        </p:nvSpPr>
+        <p:spPr>
+          <a:xfrm>
+            <a:off x="5001768" y="4206240"/>
+            <a:ext cx="2057400" cy="640080"/>
+          </a:xfrm>
+          <a:prstGeom prst="rect">
+            <a:avLst/>
+          </a:prstGeom>
+          <a:noFill/>
+        </p:spPr>
+        <p:txBody>
+          <a:bodyPr wrap="square" anchor="t" lIns="73152" rIns="73152">
+            <a:spAutoFit/>
+          </a:bodyPr>
+          <a:lstStyle/>
+          <a:p>
+            <a:pPr algn="ctr">
+              <a:spcAft>
+                <a:spcPts val="200"/>
+              </a:spcAft>
+            </a:pPr>
+            <a:r>
+              <a:rPr sz="1000" b="0" i="0">
+                <a:solidFill>
+                  <a:srgbClr val="555555"/>
+                </a:solidFill>
+                <a:latin typeface="Calibri"/>
+              </a:rPr>
+              <a:t>Operating: $2.87M</a:t>
+            </a:r>
+          </a:p>
+          <a:p>
+            <a:pPr algn="ctr">
+              <a:spcAft>
+                <a:spcPts val="200"/>
+              </a:spcAft>
+            </a:pPr>
+            <a:r>
+              <a:rPr sz="1000" b="0" i="0">
+                <a:solidFill>
+                  <a:srgbClr val="555555"/>
+                </a:solidFill>
+                <a:latin typeface="Calibri"/>
+              </a:rPr>
+              <a:t>Revenue:  $1.86M</a:t>
+            </a:r>
+          </a:p>
+          <a:p>
+            <a:pPr algn="ctr"/>
+            <a:r>
+              <a:rPr sz="1000" b="1" i="0">
+                <a:solidFill>
+                  <a:srgbClr val="111111"/>
+                </a:solidFill>
+                <a:latin typeface="Calibri"/>
+              </a:rPr>
+              <a:t>29 FTE</a:t>
+            </a:r>
+          </a:p>
+        </p:txBody>
+      </p:sp>
+      <p:sp>
+        <p:nvSpPr>
+          <p:cNvPr id="21" name="TextBox 20"/>
+          <p:cNvSpPr txBox="1"/>
+          <p:nvPr/>
+        </p:nvSpPr>
+        <p:spPr>
+          <a:xfrm>
+            <a:off x="5047488" y="4892040"/>
+            <a:ext cx="1965960" cy="731520"/>
+          </a:xfrm>
+          <a:prstGeom prst="rect">
+            <a:avLst/>
+          </a:prstGeom>
+          <a:noFill/>
+        </p:spPr>
+        <p:txBody>
+          <a:bodyPr wrap="square" anchor="t" lIns="73152" rIns="73152">
+            <a:spAutoFit/>
+          </a:bodyPr>
+          <a:lstStyle/>
+          <a:p>
+            <a:pPr algn="ctr">
+              <a:lnSpc>
+                <a:spcPct val="120000"/>
+              </a:lnSpc>
+            </a:pPr>
+            <a:r>
+              <a:rPr sz="900" b="0" i="1">
+                <a:solidFill>
+                  <a:srgbClr val="555555"/>
+                </a:solidFill>
+                <a:latin typeface="Calibri"/>
+              </a:rPr>
+              <a:t>Maximum coverage.
+Higher cost; delivers ≤14-min
+coverage to 75% of demand.</a:t>
+            </a:r>
+          </a:p>
+        </p:txBody>
+      </p:sp>
+      <p:sp>
+        <p:nvSpPr>
+          <p:cNvPr id="22" name="Rounded Rectangle 21"/>
+          <p:cNvSpPr/>
+          <p:nvPr/>
+        </p:nvSpPr>
+        <p:spPr>
+          <a:xfrm>
+            <a:off x="7214616" y="2423160"/>
+            <a:ext cx="2148840" cy="3246120"/>
+          </a:xfrm>
+          <a:prstGeom prst="roundRect">
+            <a:avLst/>
+          </a:prstGeom>
+          <a:solidFill>
+            <a:srgbClr val="FFFFFF"/>
+          </a:solidFill>
+          <a:ln w="15240">
+            <a:solidFill>
+              <a:srgbClr val="2C7FB8"/>
+            </a:solidFill>
+          </a:ln>
+        </p:spPr>
+        <p:style>
+          <a:lnRef idx="1">
+            <a:schemeClr val="accent1"/>
+          </a:lnRef>
+          <a:fillRef idx="3">
+            <a:schemeClr val="accent1"/>
+          </a:fillRef>
+          <a:effectRef idx="2">
+            <a:schemeClr val="accent1"/>
+          </a:effectRef>
+          <a:fontRef idx="minor">
+            <a:schemeClr val="lt1"/>
+          </a:fontRef>
+        </p:style>
+        <p:txBody>
+          <a:bodyPr rtlCol="0" anchor="ctr"/>
+          <a:lstStyle/>
+          <a:p/>
+        </p:txBody>
+      </p:sp>
+      <p:sp>
+        <p:nvSpPr>
+          <p:cNvPr id="23" name="TextBox 22"/>
+          <p:cNvSpPr txBox="1"/>
+          <p:nvPr/>
+        </p:nvSpPr>
+        <p:spPr>
+          <a:xfrm>
+            <a:off x="7214616" y="2514600"/>
+            <a:ext cx="2148840" cy="320040"/>
+          </a:xfrm>
+          <a:prstGeom prst="rect">
+            <a:avLst/>
+          </a:prstGeom>
+          <a:noFill/>
+        </p:spPr>
+        <p:txBody>
+          <a:bodyPr wrap="square" anchor="t" lIns="73152" rIns="73152">
+            <a:spAutoFit/>
+          </a:bodyPr>
+          <a:lstStyle/>
+          <a:p>
+            <a:pPr algn="ctr">
+              <a:lnSpc>
+                <a:spcPct val="115000"/>
+              </a:lnSpc>
+            </a:pPr>
+            <a:r>
+              <a:rPr sz="1300" b="1" i="0">
+                <a:solidFill>
+                  <a:srgbClr val="2C7FB8"/>
+                </a:solidFill>
+                <a:latin typeface="Calibri"/>
+              </a:rPr>
+              <a:t>Scenario B</a:t>
+            </a:r>
+          </a:p>
+        </p:txBody>
+      </p:sp>
+      <p:sp>
+        <p:nvSpPr>
+          <p:cNvPr id="24" name="TextBox 23"/>
+          <p:cNvSpPr txBox="1"/>
+          <p:nvPr/>
+        </p:nvSpPr>
+        <p:spPr>
+          <a:xfrm>
+            <a:off x="7214616" y="2834640"/>
+            <a:ext cx="2148840" cy="457200"/>
+          </a:xfrm>
+          <a:prstGeom prst="rect">
+            <a:avLst/>
+          </a:prstGeom>
+          <a:noFill/>
+        </p:spPr>
+        <p:txBody>
+          <a:bodyPr wrap="square" anchor="t" lIns="73152" rIns="73152">
+            <a:spAutoFit/>
+          </a:bodyPr>
+          <a:lstStyle/>
+          <a:p>
+            <a:pPr algn="ctr">
+              <a:lnSpc>
+                <a:spcPct val="115000"/>
+              </a:lnSpc>
+            </a:pPr>
+            <a:r>
+              <a:rPr sz="1000" b="0" i="1">
+                <a:solidFill>
+                  <a:srgbClr val="555555"/>
+                </a:solidFill>
+                <a:latin typeface="Calibri"/>
+              </a:rPr>
+              <a:t>All 4 peak-only (8 AM–8 PM)</a:t>
+            </a:r>
+          </a:p>
+        </p:txBody>
+      </p:sp>
+      <p:sp>
+        <p:nvSpPr>
+          <p:cNvPr id="25" name="TextBox 24"/>
+          <p:cNvSpPr txBox="1"/>
+          <p:nvPr/>
+        </p:nvSpPr>
+        <p:spPr>
+          <a:xfrm>
+            <a:off x="7214616" y="3383280"/>
+            <a:ext cx="2148840" cy="502920"/>
+          </a:xfrm>
+          <a:prstGeom prst="rect">
+            <a:avLst/>
+          </a:prstGeom>
+          <a:noFill/>
+        </p:spPr>
+        <p:txBody>
+          <a:bodyPr wrap="square" anchor="t" lIns="73152" rIns="73152">
+            <a:spAutoFit/>
+          </a:bodyPr>
+          <a:lstStyle/>
+          <a:p>
+            <a:pPr algn="ctr">
+              <a:lnSpc>
+                <a:spcPct val="115000"/>
+              </a:lnSpc>
+            </a:pPr>
+            <a:r>
+              <a:rPr sz="2600" b="1" i="0">
+                <a:solidFill>
+                  <a:srgbClr val="2C7FB8"/>
+                </a:solidFill>
+                <a:latin typeface="Calibri"/>
+              </a:rPr>
+              <a:t>$851K</a:t>
+            </a:r>
+          </a:p>
+        </p:txBody>
+      </p:sp>
+      <p:sp>
+        <p:nvSpPr>
+          <p:cNvPr id="26" name="TextBox 25"/>
+          <p:cNvSpPr txBox="1"/>
+          <p:nvPr/>
+        </p:nvSpPr>
+        <p:spPr>
+          <a:xfrm>
+            <a:off x="7214616" y="3886200"/>
+            <a:ext cx="2148840" cy="274320"/>
+          </a:xfrm>
+          <a:prstGeom prst="rect">
+            <a:avLst/>
+          </a:prstGeom>
+          <a:noFill/>
+        </p:spPr>
+        <p:txBody>
+          <a:bodyPr wrap="square" anchor="t" lIns="73152" rIns="73152">
+            <a:spAutoFit/>
+          </a:bodyPr>
+          <a:lstStyle/>
+          <a:p>
+            <a:pPr algn="ctr">
+              <a:lnSpc>
+                <a:spcPct val="115000"/>
+              </a:lnSpc>
+            </a:pPr>
+            <a:r>
+              <a:rPr sz="1000" b="0" i="1">
+                <a:solidFill>
+                  <a:srgbClr val="555555"/>
+                </a:solidFill>
+                <a:latin typeface="Calibri"/>
+              </a:rPr>
+              <a:t>net / year</a:t>
+            </a:r>
+          </a:p>
+        </p:txBody>
+      </p:sp>
+      <p:sp>
+        <p:nvSpPr>
+          <p:cNvPr id="27" name="TextBox 26"/>
+          <p:cNvSpPr txBox="1"/>
+          <p:nvPr/>
+        </p:nvSpPr>
+        <p:spPr>
+          <a:xfrm>
+            <a:off x="7260336" y="4206240"/>
+            <a:ext cx="2057400" cy="640080"/>
+          </a:xfrm>
+          <a:prstGeom prst="rect">
+            <a:avLst/>
+          </a:prstGeom>
+          <a:noFill/>
+        </p:spPr>
+        <p:txBody>
+          <a:bodyPr wrap="square" anchor="t" lIns="73152" rIns="73152">
+            <a:spAutoFit/>
+          </a:bodyPr>
+          <a:lstStyle/>
+          <a:p>
+            <a:pPr algn="ctr">
+              <a:spcAft>
+                <a:spcPts val="200"/>
+              </a:spcAft>
+            </a:pPr>
+            <a:r>
+              <a:rPr sz="1000" b="0" i="0">
+                <a:solidFill>
+                  <a:srgbClr val="555555"/>
+                </a:solidFill>
+                <a:latin typeface="Calibri"/>
+              </a:rPr>
+              <a:t>Operating: $2.06M</a:t>
+            </a:r>
+          </a:p>
+          <a:p>
+            <a:pPr algn="ctr">
+              <a:spcAft>
+                <a:spcPts val="200"/>
+              </a:spcAft>
+            </a:pPr>
+            <a:r>
+              <a:rPr sz="1000" b="0" i="0">
+                <a:solidFill>
+                  <a:srgbClr val="555555"/>
+                </a:solidFill>
+                <a:latin typeface="Calibri"/>
+              </a:rPr>
+              <a:t>Revenue:  $1.21M</a:t>
+            </a:r>
+          </a:p>
+          <a:p>
+            <a:pPr algn="ctr"/>
+            <a:r>
+              <a:rPr sz="1000" b="1" i="0">
+                <a:solidFill>
+                  <a:srgbClr val="111111"/>
+                </a:solidFill>
+                <a:latin typeface="Calibri"/>
+              </a:rPr>
+              <a:t>19 FTE</a:t>
+            </a:r>
+          </a:p>
+        </p:txBody>
+      </p:sp>
+      <p:sp>
+        <p:nvSpPr>
+          <p:cNvPr id="28" name="TextBox 27"/>
+          <p:cNvSpPr txBox="1"/>
+          <p:nvPr/>
+        </p:nvSpPr>
+        <p:spPr>
+          <a:xfrm>
+            <a:off x="7306056" y="4892040"/>
+            <a:ext cx="1965960" cy="731520"/>
+          </a:xfrm>
+          <a:prstGeom prst="rect">
+            <a:avLst/>
+          </a:prstGeom>
+          <a:noFill/>
+        </p:spPr>
+        <p:txBody>
+          <a:bodyPr wrap="square" anchor="t" lIns="73152" rIns="73152">
+            <a:spAutoFit/>
+          </a:bodyPr>
+          <a:lstStyle/>
+          <a:p>
+            <a:pPr algn="ctr">
+              <a:lnSpc>
+                <a:spcPct val="120000"/>
+              </a:lnSpc>
+            </a:pPr>
+            <a:r>
+              <a:rPr sz="900" b="0" i="1">
+                <a:solidFill>
+                  <a:srgbClr val="555555"/>
+                </a:solidFill>
+                <a:latin typeface="Calibri"/>
+              </a:rPr>
+              <a:t>Peak-hour focus — covers
+90% of call volume during
+the 12-hour daytime window.</a:t>
+            </a:r>
+          </a:p>
+        </p:txBody>
+      </p:sp>
+      <p:sp>
+        <p:nvSpPr>
+          <p:cNvPr id="29" name="Rounded Rectangle 28"/>
+          <p:cNvSpPr/>
+          <p:nvPr/>
+        </p:nvSpPr>
+        <p:spPr>
+          <a:xfrm>
+            <a:off x="9473184" y="2423160"/>
+            <a:ext cx="2148840" cy="3246120"/>
+          </a:xfrm>
+          <a:prstGeom prst="roundRect">
+            <a:avLst/>
+          </a:prstGeom>
+          <a:solidFill>
+            <a:srgbClr val="FFFFFF"/>
+          </a:solidFill>
+          <a:ln w="31750">
+            <a:solidFill>
+              <a:srgbClr val="228B22"/>
+            </a:solidFill>
+          </a:ln>
+        </p:spPr>
+        <p:style>
+          <a:lnRef idx="1">
+            <a:schemeClr val="accent1"/>
+          </a:lnRef>
+          <a:fillRef idx="3">
+            <a:schemeClr val="accent1"/>
+          </a:fillRef>
+          <a:effectRef idx="2">
+            <a:schemeClr val="accent1"/>
+          </a:effectRef>
+          <a:fontRef idx="minor">
+            <a:schemeClr val="lt1"/>
+          </a:fontRef>
+        </p:style>
+        <p:txBody>
+          <a:bodyPr rtlCol="0" anchor="ctr"/>
+          <a:lstStyle/>
+          <a:p/>
+        </p:txBody>
+      </p:sp>
+      <p:sp>
+        <p:nvSpPr>
+          <p:cNvPr id="30" name="TextBox 29"/>
+          <p:cNvSpPr txBox="1"/>
+          <p:nvPr/>
+        </p:nvSpPr>
+        <p:spPr>
+          <a:xfrm>
+            <a:off x="9473184" y="2514600"/>
+            <a:ext cx="2148840" cy="320040"/>
+          </a:xfrm>
+          <a:prstGeom prst="rect">
+            <a:avLst/>
+          </a:prstGeom>
+          <a:noFill/>
+        </p:spPr>
+        <p:txBody>
+          <a:bodyPr wrap="square" anchor="t" lIns="73152" rIns="73152">
+            <a:spAutoFit/>
+          </a:bodyPr>
+          <a:lstStyle/>
+          <a:p>
+            <a:pPr algn="ctr">
+              <a:lnSpc>
+                <a:spcPct val="115000"/>
+              </a:lnSpc>
+            </a:pPr>
+            <a:r>
+              <a:rPr sz="1300" b="1" i="0">
+                <a:solidFill>
+                  <a:srgbClr val="228B22"/>
+                </a:solidFill>
+                <a:latin typeface="Calibri"/>
+              </a:rPr>
+              <a:t>Scenario C</a:t>
+            </a:r>
+          </a:p>
+        </p:txBody>
+      </p:sp>
+      <p:sp>
+        <p:nvSpPr>
+          <p:cNvPr id="31" name="TextBox 30"/>
+          <p:cNvSpPr txBox="1"/>
+          <p:nvPr/>
+        </p:nvSpPr>
+        <p:spPr>
+          <a:xfrm>
+            <a:off x="9473184" y="2834640"/>
+            <a:ext cx="2148840" cy="457200"/>
+          </a:xfrm>
+          <a:prstGeom prst="rect">
+            <a:avLst/>
+          </a:prstGeom>
+          <a:noFill/>
+        </p:spPr>
+        <p:txBody>
+          <a:bodyPr wrap="square" anchor="t" lIns="73152" rIns="73152">
+            <a:spAutoFit/>
+          </a:bodyPr>
+          <a:lstStyle/>
+          <a:p>
+            <a:pPr algn="ctr">
+              <a:lnSpc>
+                <a:spcPct val="115000"/>
+              </a:lnSpc>
+            </a:pPr>
+            <a:r>
+              <a:rPr sz="1000" b="0" i="1">
+                <a:solidFill>
+                  <a:srgbClr val="555555"/>
+                </a:solidFill>
+                <a:latin typeface="Calibri"/>
+              </a:rPr>
+              <a:t>Hybrid: 1×24/7 + 3×peak</a:t>
+            </a:r>
+          </a:p>
+        </p:txBody>
+      </p:sp>
+      <p:sp>
+        <p:nvSpPr>
+          <p:cNvPr id="32" name="TextBox 31"/>
+          <p:cNvSpPr txBox="1"/>
+          <p:nvPr/>
+        </p:nvSpPr>
+        <p:spPr>
+          <a:xfrm>
+            <a:off x="9473184" y="3383280"/>
+            <a:ext cx="2148840" cy="502920"/>
+          </a:xfrm>
+          <a:prstGeom prst="rect">
+            <a:avLst/>
+          </a:prstGeom>
+          <a:noFill/>
+        </p:spPr>
+        <p:txBody>
+          <a:bodyPr wrap="square" anchor="t" lIns="73152" rIns="73152">
+            <a:spAutoFit/>
+          </a:bodyPr>
+          <a:lstStyle/>
+          <a:p>
+            <a:pPr algn="ctr">
+              <a:lnSpc>
+                <a:spcPct val="115000"/>
+              </a:lnSpc>
+            </a:pPr>
+            <a:r>
+              <a:rPr sz="2600" b="1" i="0">
+                <a:solidFill>
+                  <a:srgbClr val="228B22"/>
+                </a:solidFill>
+                <a:latin typeface="Calibri"/>
+              </a:rPr>
+              <a:t>$902K</a:t>
+            </a:r>
+          </a:p>
+        </p:txBody>
+      </p:sp>
+      <p:sp>
+        <p:nvSpPr>
+          <p:cNvPr id="33" name="TextBox 32"/>
+          <p:cNvSpPr txBox="1"/>
+          <p:nvPr/>
+        </p:nvSpPr>
+        <p:spPr>
+          <a:xfrm>
+            <a:off x="9473184" y="3886200"/>
+            <a:ext cx="2148840" cy="274320"/>
+          </a:xfrm>
+          <a:prstGeom prst="rect">
+            <a:avLst/>
+          </a:prstGeom>
+          <a:noFill/>
+        </p:spPr>
+        <p:txBody>
+          <a:bodyPr wrap="square" anchor="t" lIns="73152" rIns="73152">
+            <a:spAutoFit/>
+          </a:bodyPr>
+          <a:lstStyle/>
+          <a:p>
+            <a:pPr algn="ctr">
+              <a:lnSpc>
+                <a:spcPct val="115000"/>
+              </a:lnSpc>
+            </a:pPr>
+            <a:r>
+              <a:rPr sz="1000" b="0" i="1">
+                <a:solidFill>
+                  <a:srgbClr val="555555"/>
+                </a:solidFill>
+                <a:latin typeface="Calibri"/>
+              </a:rPr>
+              <a:t>net / year</a:t>
+            </a:r>
+          </a:p>
+        </p:txBody>
+      </p:sp>
+      <p:sp>
+        <p:nvSpPr>
+          <p:cNvPr id="34" name="TextBox 33"/>
+          <p:cNvSpPr txBox="1"/>
+          <p:nvPr/>
+        </p:nvSpPr>
+        <p:spPr>
+          <a:xfrm>
+            <a:off x="9518904" y="4206240"/>
+            <a:ext cx="2057400" cy="640080"/>
+          </a:xfrm>
+          <a:prstGeom prst="rect">
+            <a:avLst/>
+          </a:prstGeom>
+          <a:noFill/>
+        </p:spPr>
+        <p:txBody>
+          <a:bodyPr wrap="square" anchor="t" lIns="73152" rIns="73152">
+            <a:spAutoFit/>
+          </a:bodyPr>
+          <a:lstStyle/>
+          <a:p>
+            <a:pPr algn="ctr">
+              <a:spcAft>
+                <a:spcPts val="200"/>
+              </a:spcAft>
+            </a:pPr>
+            <a:r>
+              <a:rPr sz="1000" b="0" i="0">
+                <a:solidFill>
+                  <a:srgbClr val="555555"/>
+                </a:solidFill>
+                <a:latin typeface="Calibri"/>
+              </a:rPr>
+              <a:t>Operating: $2.33M</a:t>
+            </a:r>
+          </a:p>
+          <a:p>
+            <a:pPr algn="ctr">
+              <a:spcAft>
+                <a:spcPts val="200"/>
+              </a:spcAft>
+            </a:pPr>
+            <a:r>
+              <a:rPr sz="1000" b="0" i="0">
+                <a:solidFill>
+                  <a:srgbClr val="555555"/>
+                </a:solidFill>
+                <a:latin typeface="Calibri"/>
+              </a:rPr>
+              <a:t>Revenue:  $1.43M</a:t>
+            </a:r>
+          </a:p>
+          <a:p>
+            <a:pPr algn="ctr"/>
+            <a:r>
+              <a:rPr sz="1000" b="1" i="0">
+                <a:solidFill>
+                  <a:srgbClr val="111111"/>
+                </a:solidFill>
+                <a:latin typeface="Calibri"/>
+              </a:rPr>
+              <a:t>22 FTE</a:t>
+            </a:r>
+          </a:p>
+        </p:txBody>
+      </p:sp>
+      <p:sp>
+        <p:nvSpPr>
+          <p:cNvPr id="35" name="TextBox 34"/>
+          <p:cNvSpPr txBox="1"/>
+          <p:nvPr/>
+        </p:nvSpPr>
+        <p:spPr>
+          <a:xfrm>
+            <a:off x="9564624" y="4892040"/>
+            <a:ext cx="1965960" cy="731520"/>
+          </a:xfrm>
+          <a:prstGeom prst="rect">
+            <a:avLst/>
+          </a:prstGeom>
+          <a:noFill/>
+        </p:spPr>
+        <p:txBody>
+          <a:bodyPr wrap="square" anchor="t" lIns="73152" rIns="73152">
+            <a:spAutoFit/>
+          </a:bodyPr>
+          <a:lstStyle/>
+          <a:p>
+            <a:pPr algn="ctr">
+              <a:lnSpc>
+                <a:spcPct val="120000"/>
+              </a:lnSpc>
+            </a:pPr>
+            <a:r>
+              <a:rPr sz="900" b="0" i="1">
+                <a:solidFill>
+                  <a:srgbClr val="555555"/>
+                </a:solidFill>
+                <a:latin typeface="Calibri"/>
+              </a:rPr>
+              <a:t>Recommended balance.
+24/7 anchor + peak-only
+coverage where demand spikes.</a:t>
+            </a:r>
+          </a:p>
+        </p:txBody>
+      </p:sp>
+      <p:sp>
+        <p:nvSpPr>
+          <p:cNvPr id="36" name="TextBox 35"/>
+          <p:cNvSpPr txBox="1"/>
+          <p:nvPr/>
+        </p:nvSpPr>
+        <p:spPr>
+          <a:xfrm>
+            <a:off x="9473184" y="2167128"/>
+            <a:ext cx="2148840" cy="274320"/>
+          </a:xfrm>
+          <a:prstGeom prst="rect">
+            <a:avLst/>
+          </a:prstGeom>
+          <a:noFill/>
+        </p:spPr>
+        <p:txBody>
+          <a:bodyPr wrap="square" anchor="t" lIns="73152" rIns="73152">
+            <a:spAutoFit/>
+          </a:bodyPr>
+          <a:lstStyle/>
+          <a:p>
+            <a:pPr algn="ctr">
+              <a:lnSpc>
+                <a:spcPct val="115000"/>
+              </a:lnSpc>
+            </a:pPr>
+            <a:r>
+              <a:rPr sz="1000" b="1" i="0">
+                <a:solidFill>
+                  <a:srgbClr val="228B22"/>
+                </a:solidFill>
+                <a:latin typeface="Calibri"/>
+              </a:rPr>
+              <a:t>★ RECOMMENDED</a:t>
+            </a:r>
+          </a:p>
+        </p:txBody>
+      </p:sp>
+      <p:sp>
+        <p:nvSpPr>
+          <p:cNvPr id="37" name="TextBox 36"/>
+          <p:cNvSpPr txBox="1"/>
+          <p:nvPr/>
+        </p:nvSpPr>
+        <p:spPr>
+          <a:xfrm>
+            <a:off x="457200" y="5989320"/>
+            <a:ext cx="11247120" cy="548640"/>
+          </a:xfrm>
+          <a:prstGeom prst="rect">
+            <a:avLst/>
+          </a:prstGeom>
+          <a:noFill/>
+        </p:spPr>
+        <p:txBody>
+          <a:bodyPr wrap="square" anchor="t" lIns="73152" rIns="73152">
+            <a:spAutoFit/>
+          </a:bodyPr>
+          <a:lstStyle/>
+          <a:p>
+            <a:pPr algn="ctr">
+              <a:lnSpc>
+                <a:spcPct val="120000"/>
+              </a:lnSpc>
+            </a:pPr>
+            <a:r>
+              <a:rPr sz="1400" b="1" i="1">
+                <a:solidFill>
+                  <a:srgbClr val="111111"/>
+                </a:solidFill>
+                <a:latin typeface="Calibri"/>
+              </a:rPr>
+              <a:t>The hybrid regional network costs ≈ $900K net — within the envelope the county already spends on fragmented backup.</a:t>
+            </a:r>
+          </a:p>
+        </p:txBody>
+      </p:sp>
+      <p:sp>
+        <p:nvSpPr>
+          <p:cNvPr id="38" name="TextBox 37"/>
+          <p:cNvSpPr txBox="1"/>
+          <p:nvPr/>
+        </p:nvSpPr>
+        <p:spPr>
+          <a:xfrm>
+            <a:off x="365760" y="6537960"/>
+            <a:ext cx="11430000" cy="274320"/>
+          </a:xfrm>
+          <a:prstGeom prst="rect">
+            <a:avLst/>
+          </a:prstGeom>
+          <a:noFill/>
+        </p:spPr>
+        <p:txBody>
+          <a:bodyPr wrap="square" anchor="t" lIns="73152" rIns="73152">
+            <a:spAutoFit/>
+          </a:bodyPr>
+          <a:lstStyle/>
+          <a:p>
+            <a:pPr algn="ctr">
+              <a:lnSpc>
+                <a:spcPct val="115000"/>
+              </a:lnSpc>
+            </a:pPr>
+            <a:r>
+              <a:rPr sz="900" b="0" i="1">
+                <a:solidFill>
+                  <a:srgbClr val="777777"/>
+                </a:solidFill>
+                <a:latin typeface="Calibri"/>
+              </a:rPr>
+              <a:t>Source: Chief Peterson 24/7 ALS cost projection (6 FTEs, 700 calls/yr) scaled to K=4 · Current distributed overhead estimated from 7-dept staffing data</a:t>
+            </a:r>
+          </a:p>
+        </p:txBody>
+      </p:sp>
+    </p:spTree>
+  </p:cSld>
+  <p:clrMapOvr>
+    <a:masterClrMapping/>
+  </p:clrMapOvr>
+</p:sld>
+</file>
+
+<file path=ppt/slides/slide7.xml><?xml version="1.0" encoding="utf-8"?>
 <p:sld xmlns:a="http://schemas.openxmlformats.org/drawingml/2006/main" xmlns:p="http://schemas.openxmlformats.org/presentationml/2006/main" xmlns:r="http://schemas.openxmlformats.org/officeDocument/2006/relationships">
   <p:cSld>
     <p:spTree>

</xml_diff>